<commit_message>
Actualizar presentación desde el Excel
</commit_message>
<xml_diff>
--- a/Presentacion_Estudio_Mercado_Rural.pptx
+++ b/Presentacion_Estudio_Mercado_Rural.pptx
@@ -14773,7 +14773,7 @@
         </p:nvGraphicFramePr>
         <p:xfrm>
           <a:off x="822960" y="5074920"/>
-          <a:ext cx="10515600" cy="932688"/>
+          <a:ext cx="10515593" cy="932688"/>
         </p:xfrm>
         <a:graphic>
           <a:graphicData uri="http://schemas.openxmlformats.org/drawingml/2006/table">
@@ -14782,13 +14782,13 @@
                 <a:tableStyleId>{5C22544A-7EE6-4342-B048-85BDC9FD1C3A}</a:tableStyleId>
               </a:tblPr>
               <a:tblGrid>
-                <a:gridCol w="1828800"/>
-                <a:gridCol w="1828800"/>
-                <a:gridCol w="1485900"/>
-                <a:gridCol w="1828800"/>
-                <a:gridCol w="1371600"/>
-                <a:gridCol w="1028700"/>
-                <a:gridCol w="1143000"/>
+                <a:gridCol w="1828799"/>
+                <a:gridCol w="1828799"/>
+                <a:gridCol w="1485899"/>
+                <a:gridCol w="1828799"/>
+                <a:gridCol w="1371599"/>
+                <a:gridCol w="1028699"/>
+                <a:gridCol w="1142999"/>
               </a:tblGrid>
               <a:tr h="310896">
                 <a:tc>

</xml_diff>